<commit_message>
Upgrade route diagram aesthetics
</commit_message>
<xml_diff>
--- a/examples/academic-paper-demo/outputs/tech-route.pptx
+++ b/examples/academic-paper-demo/outputs/tech-route.pptx
@@ -87,14 +87,53 @@
       </p:grpSpPr>
       <p:sp>
         <p:nvSpPr>
-          <p:cNvPr id="2" name="Title"/>
-          <p:cNvSpPr/>
-          <p:nvPr/>
-        </p:nvSpPr>
-        <p:spPr>
-          <a:xfrm>
-            <a:off x="1150000" y="2196133"/>
-            <a:ext cx="9892000" cy="360000"/>
+          <p:cNvPr id="2" name="Title Band"/>
+          <p:cNvSpPr/>
+          <p:nvPr/>
+        </p:nvSpPr>
+        <p:spPr>
+          <a:xfrm>
+            <a:off x="3912527" y="269999"/>
+            <a:ext cx="4366945" cy="430000"/>
+          </a:xfrm>
+          <a:prstGeom prst="roundRect">
+            <a:avLst/>
+          </a:prstGeom>
+          <a:solidFill>
+            <a:srgbClr val="D9F2F2"/>
+          </a:solidFill>
+          <a:ln w="12700">
+            <a:solidFill>
+              <a:srgbClr val="D9F2F2"/>
+            </a:solidFill>
+          </a:ln>
+        </p:spPr>
+        <p:txBody>
+          <a:bodyPr wrap="square" anchor="ctr"/>
+          <a:lstStyle/>
+          <a:p>
+            <a:pPr algn="ctr"/>
+            <a:r>
+              <a:rPr lang="en-US" sz="2100" b="1">
+                <a:solidFill>
+                  <a:srgbClr val="162033"/>
+                </a:solidFill>
+              </a:rPr>
+              <a:t>多模态光伏缺陷检测技术路线图</a:t>
+            </a:r>
+          </a:p>
+        </p:txBody>
+      </p:sp>
+      <p:sp>
+        <p:nvSpPr>
+          <p:cNvPr id="3" name="Subtitle"/>
+          <p:cNvSpPr/>
+          <p:nvPr/>
+        </p:nvSpPr>
+        <p:spPr>
+          <a:xfrm>
+            <a:off x="4742527" y="714999"/>
+            <a:ext cx="2706945" cy="190000"/>
           </a:xfrm>
           <a:prstGeom prst="rect">
             <a:avLst/>
@@ -114,37 +153,71 @@
           <a:p>
             <a:pPr algn="ctr"/>
             <a:r>
-              <a:rPr lang="en-US" sz="2100" b="1">
-                <a:solidFill>
-                  <a:srgbClr val="17201D"/>
-                </a:solidFill>
-              </a:rPr>
-              <a:t>多模态光伏缺陷检测技术路线图</a:t>
-            </a:r>
-          </a:p>
-        </p:txBody>
-      </p:sp>
-      <p:sp>
-        <p:nvSpPr>
-          <p:cNvPr id="3" name="Stage 研究目标"/>
-          <p:cNvSpPr/>
-          <p:nvPr/>
-        </p:nvSpPr>
-        <p:spPr>
-          <a:xfrm>
-            <a:off x="624144" y="3001406"/>
-            <a:ext cx="1523300" cy="1376315"/>
-          </a:xfrm>
-          <a:prstGeom prst="roundRect">
-            <a:avLst/>
-          </a:prstGeom>
-          <a:solidFill>
-            <a:srgbClr val="F8FAF9"/>
-          </a:solidFill>
-          <a:ln w="12700">
-            <a:solidFill>
-              <a:srgbClr val="B8C7C1"/>
-            </a:solidFill>
+              <a:rPr lang="en-US" sz="850">
+                <a:solidFill>
+                  <a:srgbClr val="5B6472"/>
+                </a:solidFill>
+              </a:rPr>
+              <a:t>Academic method</a:t>
+            </a:r>
+          </a:p>
+          <a:p>
+            <a:pPr algn="ctr"/>
+            <a:r>
+              <a:rPr lang="en-US" sz="850">
+                <a:solidFill>
+                  <a:srgbClr val="5B6472"/>
+                </a:solidFill>
+              </a:rPr>
+              <a:t>framework demo</a:t>
+            </a:r>
+          </a:p>
+          <a:p>
+            <a:pPr algn="ctr"/>
+            <a:r>
+              <a:rPr lang="en-US" sz="850">
+                <a:solidFill>
+                  <a:srgbClr val="5B6472"/>
+                </a:solidFill>
+              </a:rPr>
+              <a:t>generated by</a:t>
+            </a:r>
+          </a:p>
+          <a:p>
+            <a:pPr algn="ctr"/>
+            <a:r>
+              <a:rPr lang="en-US" sz="850">
+                <a:solidFill>
+                  <a:srgbClr val="5B6472"/>
+                </a:solidFill>
+              </a:rPr>
+              <a:t>tech-route-maker</a:t>
+            </a:r>
+          </a:p>
+        </p:txBody>
+      </p:sp>
+      <p:sp>
+        <p:nvSpPr>
+          <p:cNvPr id="4" name="Stage 研究目标"/>
+          <p:cNvSpPr/>
+          <p:nvPr/>
+        </p:nvSpPr>
+        <p:spPr>
+          <a:xfrm>
+            <a:off x="4303779" y="890855"/>
+            <a:ext cx="4215221" cy="730905"/>
+          </a:xfrm>
+          <a:prstGeom prst="roundRect">
+            <a:avLst/>
+          </a:prstGeom>
+          <a:solidFill>
+            <a:srgbClr val="D9F2F2"/>
+          </a:solidFill>
+          <a:ln w="12700">
+            <a:solidFill>
+              <a:srgbClr val="6FAEC3"/>
+            </a:solidFill>
+            <a:prstDash val="dash"/>
           </a:ln>
         </p:spPr>
         <p:txBody>
@@ -155,7 +228,7 @@
             <a:r>
               <a:rPr lang="en-US" sz="1000">
                 <a:solidFill>
-                  <a:srgbClr val="17201D"/>
+                  <a:srgbClr val="162033"/>
                 </a:solidFill>
               </a:rPr>
               <a:t/>
@@ -165,24 +238,24 @@
       </p:sp>
       <p:sp>
         <p:nvSpPr>
-          <p:cNvPr id="4" name="Header 研究目标"/>
-          <p:cNvSpPr/>
-          <p:nvPr/>
-        </p:nvSpPr>
-        <p:spPr>
-          <a:xfrm>
-            <a:off x="624144" y="3001406"/>
-            <a:ext cx="1523300" cy="260000"/>
-          </a:xfrm>
-          <a:prstGeom prst="roundRect">
-            <a:avLst/>
-          </a:prstGeom>
-          <a:solidFill>
-            <a:srgbClr val="315C61"/>
-          </a:solidFill>
-          <a:ln w="12700">
-            <a:solidFill>
-              <a:srgbClr val="315C61"/>
+          <p:cNvPr id="5" name="Header 研究目标"/>
+          <p:cNvSpPr/>
+          <p:nvPr/>
+        </p:nvSpPr>
+        <p:spPr>
+          <a:xfrm>
+            <a:off x="4303779" y="890855"/>
+            <a:ext cx="4215221" cy="260000"/>
+          </a:xfrm>
+          <a:prstGeom prst="roundRect">
+            <a:avLst/>
+          </a:prstGeom>
+          <a:solidFill>
+            <a:srgbClr val="7BCFD0"/>
+          </a:solidFill>
+          <a:ln w="12700">
+            <a:solidFill>
+              <a:srgbClr val="7BCFD0"/>
             </a:solidFill>
           </a:ln>
         </p:spPr>
@@ -194,7 +267,7 @@
             <a:r>
               <a:rPr lang="en-US" sz="1100" b="1">
                 <a:solidFill>
-                  <a:srgbClr val="FFFFFF"/>
+                  <a:srgbClr val="122033"/>
                 </a:solidFill>
               </a:rPr>
               <a:t>研究目标</a:t>
@@ -204,25 +277,26 @@
       </p:sp>
       <p:sp>
         <p:nvSpPr>
-          <p:cNvPr id="5" name="Stage 数据构建"/>
-          <p:cNvSpPr/>
-          <p:nvPr/>
-        </p:nvSpPr>
-        <p:spPr>
-          <a:xfrm>
-            <a:off x="2508226" y="3001406"/>
-            <a:ext cx="1523300" cy="1376315"/>
-          </a:xfrm>
-          <a:prstGeom prst="roundRect">
-            <a:avLst/>
-          </a:prstGeom>
-          <a:solidFill>
-            <a:srgbClr val="F8FAF9"/>
-          </a:solidFill>
-          <a:ln w="12700">
-            <a:solidFill>
-              <a:srgbClr val="B8C7C1"/>
-            </a:solidFill>
+          <p:cNvPr id="6" name="Stage 数据构建"/>
+          <p:cNvSpPr/>
+          <p:nvPr/>
+        </p:nvSpPr>
+        <p:spPr>
+          <a:xfrm>
+            <a:off x="4303779" y="1811996"/>
+            <a:ext cx="4215221" cy="730905"/>
+          </a:xfrm>
+          <a:prstGeom prst="roundRect">
+            <a:avLst/>
+          </a:prstGeom>
+          <a:solidFill>
+            <a:srgbClr val="F7E0E8"/>
+          </a:solidFill>
+          <a:ln w="12700">
+            <a:solidFill>
+              <a:srgbClr val="6FAEC3"/>
+            </a:solidFill>
+            <a:prstDash val="dash"/>
           </a:ln>
         </p:spPr>
         <p:txBody>
@@ -233,7 +307,7 @@
             <a:r>
               <a:rPr lang="en-US" sz="1000">
                 <a:solidFill>
-                  <a:srgbClr val="17201D"/>
+                  <a:srgbClr val="162033"/>
                 </a:solidFill>
               </a:rPr>
               <a:t/>
@@ -243,24 +317,24 @@
       </p:sp>
       <p:sp>
         <p:nvSpPr>
-          <p:cNvPr id="6" name="Header 数据构建"/>
-          <p:cNvSpPr/>
-          <p:nvPr/>
-        </p:nvSpPr>
-        <p:spPr>
-          <a:xfrm>
-            <a:off x="2508226" y="3001406"/>
-            <a:ext cx="1523300" cy="260000"/>
-          </a:xfrm>
-          <a:prstGeom prst="roundRect">
-            <a:avLst/>
-          </a:prstGeom>
-          <a:solidFill>
-            <a:srgbClr val="315C61"/>
-          </a:solidFill>
-          <a:ln w="12700">
-            <a:solidFill>
-              <a:srgbClr val="315C61"/>
+          <p:cNvPr id="7" name="Header 数据构建"/>
+          <p:cNvSpPr/>
+          <p:nvPr/>
+        </p:nvSpPr>
+        <p:spPr>
+          <a:xfrm>
+            <a:off x="4303779" y="1811996"/>
+            <a:ext cx="4215221" cy="260000"/>
+          </a:xfrm>
+          <a:prstGeom prst="roundRect">
+            <a:avLst/>
+          </a:prstGeom>
+          <a:solidFill>
+            <a:srgbClr val="7BCFD0"/>
+          </a:solidFill>
+          <a:ln w="12700">
+            <a:solidFill>
+              <a:srgbClr val="7BCFD0"/>
             </a:solidFill>
           </a:ln>
         </p:spPr>
@@ -272,7 +346,7 @@
             <a:r>
               <a:rPr lang="en-US" sz="1100" b="1">
                 <a:solidFill>
-                  <a:srgbClr val="FFFFFF"/>
+                  <a:srgbClr val="122033"/>
                 </a:solidFill>
               </a:rPr>
               <a:t>数据构建</a:t>
@@ -282,25 +356,26 @@
       </p:sp>
       <p:sp>
         <p:nvSpPr>
-          <p:cNvPr id="7" name="Stage 预处理"/>
-          <p:cNvSpPr/>
-          <p:nvPr/>
-        </p:nvSpPr>
-        <p:spPr>
-          <a:xfrm>
-            <a:off x="4392308" y="3001406"/>
-            <a:ext cx="1523300" cy="1376315"/>
-          </a:xfrm>
-          <a:prstGeom prst="roundRect">
-            <a:avLst/>
-          </a:prstGeom>
-          <a:solidFill>
-            <a:srgbClr val="F8FAF9"/>
-          </a:solidFill>
-          <a:ln w="12700">
-            <a:solidFill>
-              <a:srgbClr val="B8C7C1"/>
-            </a:solidFill>
+          <p:cNvPr id="8" name="Stage 预处理"/>
+          <p:cNvSpPr/>
+          <p:nvPr/>
+        </p:nvSpPr>
+        <p:spPr>
+          <a:xfrm>
+            <a:off x="4303779" y="2733137"/>
+            <a:ext cx="4215221" cy="730905"/>
+          </a:xfrm>
+          <a:prstGeom prst="roundRect">
+            <a:avLst/>
+          </a:prstGeom>
+          <a:solidFill>
+            <a:srgbClr val="FFF1C7"/>
+          </a:solidFill>
+          <a:ln w="12700">
+            <a:solidFill>
+              <a:srgbClr val="6FAEC3"/>
+            </a:solidFill>
+            <a:prstDash val="dash"/>
           </a:ln>
         </p:spPr>
         <p:txBody>
@@ -311,7 +386,7 @@
             <a:r>
               <a:rPr lang="en-US" sz="1000">
                 <a:solidFill>
-                  <a:srgbClr val="17201D"/>
+                  <a:srgbClr val="162033"/>
                 </a:solidFill>
               </a:rPr>
               <a:t/>
@@ -321,24 +396,24 @@
       </p:sp>
       <p:sp>
         <p:nvSpPr>
-          <p:cNvPr id="8" name="Header 预处理"/>
-          <p:cNvSpPr/>
-          <p:nvPr/>
-        </p:nvSpPr>
-        <p:spPr>
-          <a:xfrm>
-            <a:off x="4392308" y="3001406"/>
-            <a:ext cx="1523300" cy="260000"/>
-          </a:xfrm>
-          <a:prstGeom prst="roundRect">
-            <a:avLst/>
-          </a:prstGeom>
-          <a:solidFill>
-            <a:srgbClr val="315C61"/>
-          </a:solidFill>
-          <a:ln w="12700">
-            <a:solidFill>
-              <a:srgbClr val="315C61"/>
+          <p:cNvPr id="9" name="Header 预处理"/>
+          <p:cNvSpPr/>
+          <p:nvPr/>
+        </p:nvSpPr>
+        <p:spPr>
+          <a:xfrm>
+            <a:off x="4303779" y="2733137"/>
+            <a:ext cx="4215221" cy="260000"/>
+          </a:xfrm>
+          <a:prstGeom prst="roundRect">
+            <a:avLst/>
+          </a:prstGeom>
+          <a:solidFill>
+            <a:srgbClr val="7BCFD0"/>
+          </a:solidFill>
+          <a:ln w="12700">
+            <a:solidFill>
+              <a:srgbClr val="7BCFD0"/>
             </a:solidFill>
           </a:ln>
         </p:spPr>
@@ -350,7 +425,7 @@
             <a:r>
               <a:rPr lang="en-US" sz="1100" b="1">
                 <a:solidFill>
-                  <a:srgbClr val="FFFFFF"/>
+                  <a:srgbClr val="122033"/>
                 </a:solidFill>
               </a:rPr>
               <a:t>预处理</a:t>
@@ -360,25 +435,26 @@
       </p:sp>
       <p:sp>
         <p:nvSpPr>
-          <p:cNvPr id="9" name="Stage 核心方法"/>
-          <p:cNvSpPr/>
-          <p:nvPr/>
-        </p:nvSpPr>
-        <p:spPr>
-          <a:xfrm>
-            <a:off x="6276390" y="3001406"/>
-            <a:ext cx="1523300" cy="1376315"/>
-          </a:xfrm>
-          <a:prstGeom prst="roundRect">
-            <a:avLst/>
-          </a:prstGeom>
-          <a:solidFill>
-            <a:srgbClr val="F8FAF9"/>
-          </a:solidFill>
-          <a:ln w="12700">
-            <a:solidFill>
-              <a:srgbClr val="B8C7C1"/>
-            </a:solidFill>
+          <p:cNvPr id="10" name="Stage 核心方法"/>
+          <p:cNvSpPr/>
+          <p:nvPr/>
+        </p:nvSpPr>
+        <p:spPr>
+          <a:xfrm>
+            <a:off x="4303779" y="3654279"/>
+            <a:ext cx="4215221" cy="730905"/>
+          </a:xfrm>
+          <a:prstGeom prst="roundRect">
+            <a:avLst/>
+          </a:prstGeom>
+          <a:solidFill>
+            <a:srgbClr val="DDECF9"/>
+          </a:solidFill>
+          <a:ln w="12700">
+            <a:solidFill>
+              <a:srgbClr val="6FAEC3"/>
+            </a:solidFill>
+            <a:prstDash val="dash"/>
           </a:ln>
         </p:spPr>
         <p:txBody>
@@ -389,7 +465,7 @@
             <a:r>
               <a:rPr lang="en-US" sz="1000">
                 <a:solidFill>
-                  <a:srgbClr val="17201D"/>
+                  <a:srgbClr val="162033"/>
                 </a:solidFill>
               </a:rPr>
               <a:t/>
@@ -399,24 +475,24 @@
       </p:sp>
       <p:sp>
         <p:nvSpPr>
-          <p:cNvPr id="10" name="Header 核心方法"/>
-          <p:cNvSpPr/>
-          <p:nvPr/>
-        </p:nvSpPr>
-        <p:spPr>
-          <a:xfrm>
-            <a:off x="6276390" y="3001406"/>
-            <a:ext cx="1523300" cy="260000"/>
-          </a:xfrm>
-          <a:prstGeom prst="roundRect">
-            <a:avLst/>
-          </a:prstGeom>
-          <a:solidFill>
-            <a:srgbClr val="315C61"/>
-          </a:solidFill>
-          <a:ln w="12700">
-            <a:solidFill>
-              <a:srgbClr val="315C61"/>
+          <p:cNvPr id="11" name="Header 核心方法"/>
+          <p:cNvSpPr/>
+          <p:nvPr/>
+        </p:nvSpPr>
+        <p:spPr>
+          <a:xfrm>
+            <a:off x="4303779" y="3654279"/>
+            <a:ext cx="4215221" cy="260000"/>
+          </a:xfrm>
+          <a:prstGeom prst="roundRect">
+            <a:avLst/>
+          </a:prstGeom>
+          <a:solidFill>
+            <a:srgbClr val="7BCFD0"/>
+          </a:solidFill>
+          <a:ln w="12700">
+            <a:solidFill>
+              <a:srgbClr val="7BCFD0"/>
             </a:solidFill>
           </a:ln>
         </p:spPr>
@@ -428,7 +504,7 @@
             <a:r>
               <a:rPr lang="en-US" sz="1100" b="1">
                 <a:solidFill>
-                  <a:srgbClr val="FFFFFF"/>
+                  <a:srgbClr val="122033"/>
                 </a:solidFill>
               </a:rPr>
               <a:t>核心方法</a:t>
@@ -438,25 +514,26 @@
       </p:sp>
       <p:sp>
         <p:nvSpPr>
-          <p:cNvPr id="11" name="Stage 训练推理"/>
-          <p:cNvSpPr/>
-          <p:nvPr/>
-        </p:nvSpPr>
-        <p:spPr>
-          <a:xfrm>
-            <a:off x="8160473" y="3001406"/>
-            <a:ext cx="1523300" cy="1376315"/>
-          </a:xfrm>
-          <a:prstGeom prst="roundRect">
-            <a:avLst/>
-          </a:prstGeom>
-          <a:solidFill>
-            <a:srgbClr val="F8FAF9"/>
-          </a:solidFill>
-          <a:ln w="12700">
-            <a:solidFill>
-              <a:srgbClr val="B8C7C1"/>
-            </a:solidFill>
+          <p:cNvPr id="12" name="Stage 训练推理"/>
+          <p:cNvSpPr/>
+          <p:nvPr/>
+        </p:nvSpPr>
+        <p:spPr>
+          <a:xfrm>
+            <a:off x="4303779" y="4575420"/>
+            <a:ext cx="4215221" cy="730905"/>
+          </a:xfrm>
+          <a:prstGeom prst="roundRect">
+            <a:avLst/>
+          </a:prstGeom>
+          <a:solidFill>
+            <a:srgbClr val="E6F4D7"/>
+          </a:solidFill>
+          <a:ln w="12700">
+            <a:solidFill>
+              <a:srgbClr val="6FAEC3"/>
+            </a:solidFill>
+            <a:prstDash val="dash"/>
           </a:ln>
         </p:spPr>
         <p:txBody>
@@ -467,7 +544,7 @@
             <a:r>
               <a:rPr lang="en-US" sz="1000">
                 <a:solidFill>
-                  <a:srgbClr val="17201D"/>
+                  <a:srgbClr val="162033"/>
                 </a:solidFill>
               </a:rPr>
               <a:t/>
@@ -477,24 +554,24 @@
       </p:sp>
       <p:sp>
         <p:nvSpPr>
-          <p:cNvPr id="12" name="Header 训练推理"/>
-          <p:cNvSpPr/>
-          <p:nvPr/>
-        </p:nvSpPr>
-        <p:spPr>
-          <a:xfrm>
-            <a:off x="8160473" y="3001406"/>
-            <a:ext cx="1523300" cy="260000"/>
-          </a:xfrm>
-          <a:prstGeom prst="roundRect">
-            <a:avLst/>
-          </a:prstGeom>
-          <a:solidFill>
-            <a:srgbClr val="315C61"/>
-          </a:solidFill>
-          <a:ln w="12700">
-            <a:solidFill>
-              <a:srgbClr val="315C61"/>
+          <p:cNvPr id="13" name="Header 训练推理"/>
+          <p:cNvSpPr/>
+          <p:nvPr/>
+        </p:nvSpPr>
+        <p:spPr>
+          <a:xfrm>
+            <a:off x="4303779" y="4575420"/>
+            <a:ext cx="4215221" cy="260000"/>
+          </a:xfrm>
+          <a:prstGeom prst="roundRect">
+            <a:avLst/>
+          </a:prstGeom>
+          <a:solidFill>
+            <a:srgbClr val="7BCFD0"/>
+          </a:solidFill>
+          <a:ln w="12700">
+            <a:solidFill>
+              <a:srgbClr val="7BCFD0"/>
             </a:solidFill>
           </a:ln>
         </p:spPr>
@@ -506,7 +583,7 @@
             <a:r>
               <a:rPr lang="en-US" sz="1100" b="1">
                 <a:solidFill>
-                  <a:srgbClr val="FFFFFF"/>
+                  <a:srgbClr val="122033"/>
                 </a:solidFill>
               </a:rPr>
               <a:t>训练推理</a:t>
@@ -516,25 +593,26 @@
       </p:sp>
       <p:sp>
         <p:nvSpPr>
-          <p:cNvPr id="13" name="Stage 验证输出"/>
-          <p:cNvSpPr/>
-          <p:nvPr/>
-        </p:nvSpPr>
-        <p:spPr>
-          <a:xfrm>
-            <a:off x="10044555" y="3001406"/>
-            <a:ext cx="1523300" cy="1376315"/>
-          </a:xfrm>
-          <a:prstGeom prst="roundRect">
-            <a:avLst/>
-          </a:prstGeom>
-          <a:solidFill>
-            <a:srgbClr val="F8FAF9"/>
-          </a:solidFill>
-          <a:ln w="12700">
-            <a:solidFill>
-              <a:srgbClr val="B8C7C1"/>
-            </a:solidFill>
+          <p:cNvPr id="14" name="Stage 验证输出"/>
+          <p:cNvSpPr/>
+          <p:nvPr/>
+        </p:nvSpPr>
+        <p:spPr>
+          <a:xfrm>
+            <a:off x="4303779" y="5496561"/>
+            <a:ext cx="4215221" cy="730905"/>
+          </a:xfrm>
+          <a:prstGeom prst="roundRect">
+            <a:avLst/>
+          </a:prstGeom>
+          <a:solidFill>
+            <a:srgbClr val="F6E7D7"/>
+          </a:solidFill>
+          <a:ln w="12700">
+            <a:solidFill>
+              <a:srgbClr val="6FAEC3"/>
+            </a:solidFill>
+            <a:prstDash val="dash"/>
           </a:ln>
         </p:spPr>
         <p:txBody>
@@ -545,7 +623,7 @@
             <a:r>
               <a:rPr lang="en-US" sz="1000">
                 <a:solidFill>
-                  <a:srgbClr val="17201D"/>
+                  <a:srgbClr val="162033"/>
                 </a:solidFill>
               </a:rPr>
               <a:t/>
@@ -555,24 +633,24 @@
       </p:sp>
       <p:sp>
         <p:nvSpPr>
-          <p:cNvPr id="14" name="Header 验证输出"/>
-          <p:cNvSpPr/>
-          <p:nvPr/>
-        </p:nvSpPr>
-        <p:spPr>
-          <a:xfrm>
-            <a:off x="10044555" y="3001406"/>
-            <a:ext cx="1523300" cy="260000"/>
-          </a:xfrm>
-          <a:prstGeom prst="roundRect">
-            <a:avLst/>
-          </a:prstGeom>
-          <a:solidFill>
-            <a:srgbClr val="315C61"/>
-          </a:solidFill>
-          <a:ln w="12700">
-            <a:solidFill>
-              <a:srgbClr val="315C61"/>
+          <p:cNvPr id="15" name="Header 验证输出"/>
+          <p:cNvSpPr/>
+          <p:nvPr/>
+        </p:nvSpPr>
+        <p:spPr>
+          <a:xfrm>
+            <a:off x="4303779" y="5496561"/>
+            <a:ext cx="4215221" cy="260000"/>
+          </a:xfrm>
+          <a:prstGeom prst="roundRect">
+            <a:avLst/>
+          </a:prstGeom>
+          <a:solidFill>
+            <a:srgbClr val="7BCFD0"/>
+          </a:solidFill>
+          <a:ln w="12700">
+            <a:solidFill>
+              <a:srgbClr val="7BCFD0"/>
             </a:solidFill>
           </a:ln>
         </p:spPr>
@@ -584,7 +662,7 @@
             <a:r>
               <a:rPr lang="en-US" sz="1100" b="1">
                 <a:solidFill>
-                  <a:srgbClr val="FFFFFF"/>
+                  <a:srgbClr val="122033"/>
                 </a:solidFill>
               </a:rPr>
               <a:t>验证输出</a:t>
@@ -592,28 +670,6 @@
           </a:p>
         </p:txBody>
       </p:sp>
-      <p:cxnSp>
-        <p:nvCxnSpPr>
-          <p:cNvPr id="15" name="Connector 15"/>
-          <p:cNvCxnSpPr/>
-          <p:nvPr/>
-        </p:nvCxnSpPr>
-        <p:spPr>
-          <a:xfrm>
-            <a:off x="1385794" y="3569304"/>
-            <a:ext cx="1884082" cy="1"/>
-          </a:xfrm>
-          <a:prstGeom prst="line">
-            <a:avLst/>
-          </a:prstGeom>
-          <a:ln w="19050">
-            <a:solidFill>
-              <a:srgbClr val="315C61"/>
-            </a:solidFill>
-            <a:headEnd type="triangle"/>
-          </a:ln>
-        </p:spPr>
-      </p:cxnSp>
       <p:cxnSp>
         <p:nvCxnSpPr>
           <p:cNvPr id="16" name="Connector 16"/>
@@ -621,16 +677,16 @@
           <p:nvPr/>
         </p:nvCxnSpPr>
         <p:spPr>
-          <a:xfrm>
-            <a:off x="3269876" y="3569304"/>
-            <a:ext cx="1" cy="494404"/>
+          <a:xfrm flipH="1">
+            <a:off x="5425168" y="1346420"/>
+            <a:ext cx="986221" cy="921141"/>
           </a:xfrm>
           <a:prstGeom prst="line">
             <a:avLst/>
           </a:prstGeom>
           <a:ln w="19050">
             <a:solidFill>
-              <a:srgbClr val="315C61"/>
+              <a:srgbClr val="2C6A93"/>
             </a:solidFill>
             <a:headEnd type="triangle"/>
           </a:ln>
@@ -643,16 +699,16 @@
           <p:nvPr/>
         </p:nvCxnSpPr>
         <p:spPr>
-          <a:xfrm flipV="1">
-            <a:off x="3269876" y="3569304"/>
-            <a:ext cx="1884082" cy="494404"/>
+          <a:xfrm>
+            <a:off x="5425168" y="2267561"/>
+            <a:ext cx="1972443" cy="1"/>
           </a:xfrm>
           <a:prstGeom prst="line">
             <a:avLst/>
           </a:prstGeom>
           <a:ln w="19050">
             <a:solidFill>
-              <a:srgbClr val="315C61"/>
+              <a:srgbClr val="2C6A93"/>
             </a:solidFill>
             <a:headEnd type="triangle"/>
           </a:ln>
@@ -665,16 +721,16 @@
           <p:nvPr/>
         </p:nvCxnSpPr>
         <p:spPr>
-          <a:xfrm>
-            <a:off x="5153958" y="3569304"/>
-            <a:ext cx="1" cy="494404"/>
+          <a:xfrm flipH="1">
+            <a:off x="5425168" y="2267561"/>
+            <a:ext cx="1972443" cy="921141"/>
           </a:xfrm>
           <a:prstGeom prst="line">
             <a:avLst/>
           </a:prstGeom>
           <a:ln w="19050">
             <a:solidFill>
-              <a:srgbClr val="315C61"/>
+              <a:srgbClr val="2C6A93"/>
             </a:solidFill>
             <a:headEnd type="triangle"/>
           </a:ln>
@@ -687,16 +743,16 @@
           <p:nvPr/>
         </p:nvCxnSpPr>
         <p:spPr>
-          <a:xfrm flipV="1">
-            <a:off x="5153958" y="3569304"/>
-            <a:ext cx="1884082" cy="494404"/>
+          <a:xfrm>
+            <a:off x="5425168" y="3188702"/>
+            <a:ext cx="1972443" cy="1"/>
           </a:xfrm>
           <a:prstGeom prst="line">
             <a:avLst/>
           </a:prstGeom>
           <a:ln w="19050">
             <a:solidFill>
-              <a:srgbClr val="315C61"/>
+              <a:srgbClr val="2C6A93"/>
             </a:solidFill>
             <a:headEnd type="triangle"/>
           </a:ln>
@@ -709,16 +765,16 @@
           <p:nvPr/>
         </p:nvCxnSpPr>
         <p:spPr>
-          <a:xfrm>
-            <a:off x="7038041" y="3569304"/>
-            <a:ext cx="1" cy="494404"/>
+          <a:xfrm flipH="1">
+            <a:off x="5425168" y="3188702"/>
+            <a:ext cx="1972443" cy="921141"/>
           </a:xfrm>
           <a:prstGeom prst="line">
             <a:avLst/>
           </a:prstGeom>
           <a:ln w="19050">
             <a:solidFill>
-              <a:srgbClr val="315C61"/>
+              <a:srgbClr val="2C6A93"/>
             </a:solidFill>
             <a:headEnd type="triangle"/>
           </a:ln>
@@ -731,16 +787,16 @@
           <p:nvPr/>
         </p:nvCxnSpPr>
         <p:spPr>
-          <a:xfrm flipV="1">
-            <a:off x="7038041" y="3569304"/>
-            <a:ext cx="1884082" cy="494404"/>
+          <a:xfrm>
+            <a:off x="5425168" y="4109843"/>
+            <a:ext cx="1972443" cy="1"/>
           </a:xfrm>
           <a:prstGeom prst="line">
             <a:avLst/>
           </a:prstGeom>
           <a:ln w="19050">
             <a:solidFill>
-              <a:srgbClr val="315C61"/>
+              <a:srgbClr val="2C6A93"/>
             </a:solidFill>
             <a:headEnd type="triangle"/>
           </a:ln>
@@ -753,16 +809,16 @@
           <p:nvPr/>
         </p:nvCxnSpPr>
         <p:spPr>
-          <a:xfrm>
-            <a:off x="8922123" y="3569304"/>
-            <a:ext cx="1" cy="494404"/>
+          <a:xfrm flipH="1">
+            <a:off x="5425168" y="4109843"/>
+            <a:ext cx="1972443" cy="921141"/>
           </a:xfrm>
           <a:prstGeom prst="line">
             <a:avLst/>
           </a:prstGeom>
           <a:ln w="19050">
             <a:solidFill>
-              <a:srgbClr val="315C61"/>
+              <a:srgbClr val="2C6A93"/>
             </a:solidFill>
             <a:headEnd type="triangle"/>
           </a:ln>
@@ -775,16 +831,16 @@
           <p:nvPr/>
         </p:nvCxnSpPr>
         <p:spPr>
-          <a:xfrm flipV="1">
-            <a:off x="8922123" y="3569304"/>
-            <a:ext cx="1884082" cy="494404"/>
+          <a:xfrm>
+            <a:off x="5425168" y="5030984"/>
+            <a:ext cx="1972443" cy="1"/>
           </a:xfrm>
           <a:prstGeom prst="line">
             <a:avLst/>
           </a:prstGeom>
           <a:ln w="19050">
             <a:solidFill>
-              <a:srgbClr val="315C61"/>
+              <a:srgbClr val="2C6A93"/>
             </a:solidFill>
             <a:headEnd type="triangle"/>
           </a:ln>
@@ -797,31 +853,53 @@
           <p:nvPr/>
         </p:nvCxnSpPr>
         <p:spPr>
-          <a:xfrm>
-            <a:off x="10806205" y="3569304"/>
-            <a:ext cx="1" cy="494404"/>
+          <a:xfrm flipH="1">
+            <a:off x="5425168" y="5030984"/>
+            <a:ext cx="1972443" cy="921141"/>
           </a:xfrm>
           <a:prstGeom prst="line">
             <a:avLst/>
           </a:prstGeom>
           <a:ln w="19050">
             <a:solidFill>
-              <a:srgbClr val="315C61"/>
+              <a:srgbClr val="2C6A93"/>
             </a:solidFill>
             <a:headEnd type="triangle"/>
           </a:ln>
         </p:spPr>
       </p:cxnSp>
-      <p:sp>
-        <p:nvSpPr>
-          <p:cNvPr id="25" name="Node objective_goal"/>
-          <p:cNvSpPr/>
-          <p:nvPr/>
-        </p:nvSpPr>
-        <p:spPr>
-          <a:xfrm>
-            <a:off x="791172" y="3375550"/>
-            <a:ext cx="1189243" cy="387506"/>
+      <p:cxnSp>
+        <p:nvCxnSpPr>
+          <p:cNvPr id="25" name="Connector 25"/>
+          <p:cNvCxnSpPr/>
+          <p:nvPr/>
+        </p:nvCxnSpPr>
+        <p:spPr>
+          <a:xfrm>
+            <a:off x="5425168" y="5952125"/>
+            <a:ext cx="1972443" cy="1"/>
+          </a:xfrm>
+          <a:prstGeom prst="line">
+            <a:avLst/>
+          </a:prstGeom>
+          <a:ln w="19050">
+            <a:solidFill>
+              <a:srgbClr val="2C6A93"/>
+            </a:solidFill>
+            <a:headEnd type="triangle"/>
+          </a:ln>
+        </p:spPr>
+      </p:cxnSp>
+      <p:sp>
+        <p:nvSpPr>
+          <p:cNvPr id="26" name="Node objective_goal"/>
+          <p:cNvSpPr/>
+          <p:nvPr/>
+        </p:nvSpPr>
+        <p:spPr>
+          <a:xfrm>
+            <a:off x="4478996" y="1191227"/>
+            <a:ext cx="3864787" cy="310384"/>
           </a:xfrm>
           <a:prstGeom prst="roundRect">
             <a:avLst/>
@@ -831,7 +909,7 @@
           </a:solidFill>
           <a:ln w="12700">
             <a:solidFill>
-              <a:srgbClr val="8BAAA5"/>
+              <a:srgbClr val="9FB6C4"/>
             </a:solidFill>
           </a:ln>
         </p:spPr>
@@ -843,7 +921,7 @@
             <a:r>
               <a:rPr lang="en-US" sz="1050">
                 <a:solidFill>
-                  <a:srgbClr val="17201D"/>
+                  <a:srgbClr val="162033"/>
                 </a:solidFill>
               </a:rPr>
               <a:t>明确检测目标</a:t>
@@ -853,14 +931,14 @@
       </p:sp>
       <p:sp>
         <p:nvSpPr>
-          <p:cNvPr id="26" name="Node data_capture"/>
-          <p:cNvSpPr/>
-          <p:nvPr/>
-        </p:nvSpPr>
-        <p:spPr>
-          <a:xfrm>
-            <a:off x="2675254" y="3375550"/>
-            <a:ext cx="1189243" cy="387506"/>
+          <p:cNvPr id="27" name="Node data_capture"/>
+          <p:cNvSpPr/>
+          <p:nvPr/>
+        </p:nvSpPr>
+        <p:spPr>
+          <a:xfrm>
+            <a:off x="4478996" y="2112368"/>
+            <a:ext cx="1892344" cy="310384"/>
           </a:xfrm>
           <a:prstGeom prst="roundRect">
             <a:avLst/>
@@ -870,7 +948,7 @@
           </a:solidFill>
           <a:ln w="12700">
             <a:solidFill>
-              <a:srgbClr val="8BAAA5"/>
+              <a:srgbClr val="9FB6C4"/>
             </a:solidFill>
           </a:ln>
         </p:spPr>
@@ -882,7 +960,7 @@
             <a:r>
               <a:rPr lang="en-US" sz="1050">
                 <a:solidFill>
-                  <a:srgbClr val="17201D"/>
+                  <a:srgbClr val="162033"/>
                 </a:solidFill>
               </a:rPr>
               <a:t>采集多模态图像</a:t>
@@ -892,14 +970,14 @@
       </p:sp>
       <p:sp>
         <p:nvSpPr>
-          <p:cNvPr id="27" name="Node data_screen"/>
-          <p:cNvSpPr/>
-          <p:nvPr/>
-        </p:nvSpPr>
-        <p:spPr>
-          <a:xfrm>
-            <a:off x="2675254" y="3869955"/>
-            <a:ext cx="1189243" cy="387506"/>
+          <p:cNvPr id="28" name="Node data_screen"/>
+          <p:cNvSpPr/>
+          <p:nvPr/>
+        </p:nvSpPr>
+        <p:spPr>
+          <a:xfrm>
+            <a:off x="6451440" y="2112368"/>
+            <a:ext cx="1892344" cy="310384"/>
           </a:xfrm>
           <a:prstGeom prst="roundRect">
             <a:avLst/>
@@ -909,7 +987,7 @@
           </a:solidFill>
           <a:ln w="12700">
             <a:solidFill>
-              <a:srgbClr val="8BAAA5"/>
+              <a:srgbClr val="9FB6C4"/>
             </a:solidFill>
           </a:ln>
         </p:spPr>
@@ -921,7 +999,7 @@
             <a:r>
               <a:rPr lang="en-US" sz="1050">
                 <a:solidFill>
-                  <a:srgbClr val="17201D"/>
+                  <a:srgbClr val="162033"/>
                 </a:solidFill>
               </a:rPr>
               <a:t>图像质量筛选</a:t>
@@ -931,14 +1009,14 @@
       </p:sp>
       <p:sp>
         <p:nvSpPr>
-          <p:cNvPr id="28" name="Node preprocess_align"/>
-          <p:cNvSpPr/>
-          <p:nvPr/>
-        </p:nvSpPr>
-        <p:spPr>
-          <a:xfrm>
-            <a:off x="4559337" y="3375550"/>
-            <a:ext cx="1189243" cy="387506"/>
+          <p:cNvPr id="29" name="Node preprocess_align"/>
+          <p:cNvSpPr/>
+          <p:nvPr/>
+        </p:nvSpPr>
+        <p:spPr>
+          <a:xfrm>
+            <a:off x="4478996" y="3033510"/>
+            <a:ext cx="1892344" cy="310384"/>
           </a:xfrm>
           <a:prstGeom prst="roundRect">
             <a:avLst/>
@@ -948,7 +1026,7 @@
           </a:solidFill>
           <a:ln w="12700">
             <a:solidFill>
-              <a:srgbClr val="8BAAA5"/>
+              <a:srgbClr val="9FB6C4"/>
             </a:solidFill>
           </a:ln>
         </p:spPr>
@@ -960,7 +1038,7 @@
             <a:r>
               <a:rPr lang="en-US" sz="1050">
                 <a:solidFill>
-                  <a:srgbClr val="17201D"/>
+                  <a:srgbClr val="162033"/>
                 </a:solidFill>
               </a:rPr>
               <a:t>图像配准与标注</a:t>
@@ -970,14 +1048,14 @@
       </p:sp>
       <p:sp>
         <p:nvSpPr>
-          <p:cNvPr id="29" name="Node preprocess_split"/>
-          <p:cNvSpPr/>
-          <p:nvPr/>
-        </p:nvSpPr>
-        <p:spPr>
-          <a:xfrm>
-            <a:off x="4559337" y="3869955"/>
-            <a:ext cx="1189243" cy="387506"/>
+          <p:cNvPr id="30" name="Node preprocess_split"/>
+          <p:cNvSpPr/>
+          <p:nvPr/>
+        </p:nvSpPr>
+        <p:spPr>
+          <a:xfrm>
+            <a:off x="6451440" y="3033510"/>
+            <a:ext cx="1892344" cy="310384"/>
           </a:xfrm>
           <a:prstGeom prst="roundRect">
             <a:avLst/>
@@ -987,7 +1065,7 @@
           </a:solidFill>
           <a:ln w="12700">
             <a:solidFill>
-              <a:srgbClr val="8BAAA5"/>
+              <a:srgbClr val="9FB6C4"/>
             </a:solidFill>
           </a:ln>
         </p:spPr>
@@ -999,7 +1077,7 @@
             <a:r>
               <a:rPr lang="en-US" sz="1050">
                 <a:solidFill>
-                  <a:srgbClr val="17201D"/>
+                  <a:srgbClr val="162033"/>
                 </a:solidFill>
               </a:rPr>
               <a:t>增强并划分数据</a:t>
@@ -1009,14 +1087,14 @@
       </p:sp>
       <p:sp>
         <p:nvSpPr>
-          <p:cNvPr id="30" name="Node method_baseline"/>
-          <p:cNvSpPr/>
-          <p:nvPr/>
-        </p:nvSpPr>
-        <p:spPr>
-          <a:xfrm>
-            <a:off x="6443419" y="3375550"/>
-            <a:ext cx="1189243" cy="387506"/>
+          <p:cNvPr id="31" name="Node method_baseline"/>
+          <p:cNvSpPr/>
+          <p:nvPr/>
+        </p:nvSpPr>
+        <p:spPr>
+          <a:xfrm>
+            <a:off x="4478996" y="3954651"/>
+            <a:ext cx="1892344" cy="310384"/>
           </a:xfrm>
           <a:prstGeom prst="roundRect">
             <a:avLst/>
@@ -1026,7 +1104,7 @@
           </a:solidFill>
           <a:ln w="12700">
             <a:solidFill>
-              <a:srgbClr val="8BAAA5"/>
+              <a:srgbClr val="9FB6C4"/>
             </a:solidFill>
           </a:ln>
         </p:spPr>
@@ -1038,7 +1116,7 @@
             <a:r>
               <a:rPr lang="en-US" sz="1050">
                 <a:solidFill>
-                  <a:srgbClr val="17201D"/>
+                  <a:srgbClr val="162033"/>
                 </a:solidFill>
               </a:rPr>
               <a:t>建立基线检测器</a:t>
@@ -1048,14 +1126,14 @@
       </p:sp>
       <p:sp>
         <p:nvSpPr>
-          <p:cNvPr id="31" name="Node method_fusion"/>
-          <p:cNvSpPr/>
-          <p:nvPr/>
-        </p:nvSpPr>
-        <p:spPr>
-          <a:xfrm>
-            <a:off x="6443419" y="3869955"/>
-            <a:ext cx="1189243" cy="387506"/>
+          <p:cNvPr id="32" name="Node method_fusion"/>
+          <p:cNvSpPr/>
+          <p:nvPr/>
+        </p:nvSpPr>
+        <p:spPr>
+          <a:xfrm>
+            <a:off x="6451440" y="3954651"/>
+            <a:ext cx="1892344" cy="310384"/>
           </a:xfrm>
           <a:prstGeom prst="roundRect">
             <a:avLst/>
@@ -1065,7 +1143,7 @@
           </a:solidFill>
           <a:ln w="12700">
             <a:solidFill>
-              <a:srgbClr val="8BAAA5"/>
+              <a:srgbClr val="9FB6C4"/>
             </a:solidFill>
           </a:ln>
         </p:spPr>
@@ -1077,7 +1155,7 @@
             <a:r>
               <a:rPr lang="en-US" sz="1050">
                 <a:solidFill>
-                  <a:srgbClr val="17201D"/>
+                  <a:srgbClr val="162033"/>
                 </a:solidFill>
               </a:rPr>
               <a:t>构建特征融合检测器</a:t>
@@ -1087,14 +1165,14 @@
       </p:sp>
       <p:sp>
         <p:nvSpPr>
-          <p:cNvPr id="32" name="Node train_supervised"/>
-          <p:cNvSpPr/>
-          <p:nvPr/>
-        </p:nvSpPr>
-        <p:spPr>
-          <a:xfrm>
-            <a:off x="8327501" y="3375550"/>
-            <a:ext cx="1189243" cy="387506"/>
+          <p:cNvPr id="33" name="Node train_supervised"/>
+          <p:cNvSpPr/>
+          <p:nvPr/>
+        </p:nvSpPr>
+        <p:spPr>
+          <a:xfrm>
+            <a:off x="4478996" y="4875792"/>
+            <a:ext cx="1892344" cy="310384"/>
           </a:xfrm>
           <a:prstGeom prst="roundRect">
             <a:avLst/>
@@ -1104,7 +1182,7 @@
           </a:solidFill>
           <a:ln w="12700">
             <a:solidFill>
-              <a:srgbClr val="8BAAA5"/>
+              <a:srgbClr val="9FB6C4"/>
             </a:solidFill>
           </a:ln>
         </p:spPr>
@@ -1116,7 +1194,7 @@
             <a:r>
               <a:rPr lang="en-US" sz="1050">
                 <a:solidFill>
-                  <a:srgbClr val="17201D"/>
+                  <a:srgbClr val="162033"/>
                 </a:solidFill>
               </a:rPr>
               <a:t>训练与指标优化</a:t>
@@ -1126,14 +1204,14 @@
       </p:sp>
       <p:sp>
         <p:nvSpPr>
-          <p:cNvPr id="33" name="Node infer_filter"/>
-          <p:cNvSpPr/>
-          <p:nvPr/>
-        </p:nvSpPr>
-        <p:spPr>
-          <a:xfrm>
-            <a:off x="8327501" y="3869955"/>
-            <a:ext cx="1189243" cy="387506"/>
+          <p:cNvPr id="34" name="Node infer_filter"/>
+          <p:cNvSpPr/>
+          <p:nvPr/>
+        </p:nvSpPr>
+        <p:spPr>
+          <a:xfrm>
+            <a:off x="6451440" y="4875792"/>
+            <a:ext cx="1892344" cy="310384"/>
           </a:xfrm>
           <a:prstGeom prst="roundRect">
             <a:avLst/>
@@ -1143,7 +1221,7 @@
           </a:solidFill>
           <a:ln w="12700">
             <a:solidFill>
-              <a:srgbClr val="8BAAA5"/>
+              <a:srgbClr val="9FB6C4"/>
             </a:solidFill>
           </a:ln>
         </p:spPr>
@@ -1155,7 +1233,7 @@
             <a:r>
               <a:rPr lang="en-US" sz="1050">
                 <a:solidFill>
-                  <a:srgbClr val="17201D"/>
+                  <a:srgbClr val="162033"/>
                 </a:solidFill>
               </a:rPr>
               <a:t>推理并筛选结果</a:t>
@@ -1165,14 +1243,14 @@
       </p:sp>
       <p:sp>
         <p:nvSpPr>
-          <p:cNvPr id="34" name="Node eval_compare"/>
-          <p:cNvSpPr/>
-          <p:nvPr/>
-        </p:nvSpPr>
-        <p:spPr>
-          <a:xfrm>
-            <a:off x="10211584" y="3375550"/>
-            <a:ext cx="1189243" cy="387506"/>
+          <p:cNvPr id="35" name="Node eval_compare"/>
+          <p:cNvSpPr/>
+          <p:nvPr/>
+        </p:nvSpPr>
+        <p:spPr>
+          <a:xfrm>
+            <a:off x="4478996" y="5796933"/>
+            <a:ext cx="1892344" cy="310384"/>
           </a:xfrm>
           <a:prstGeom prst="roundRect">
             <a:avLst/>
@@ -1182,7 +1260,7 @@
           </a:solidFill>
           <a:ln w="12700">
             <a:solidFill>
-              <a:srgbClr val="8BAAA5"/>
+              <a:srgbClr val="9FB6C4"/>
             </a:solidFill>
           </a:ln>
         </p:spPr>
@@ -1194,7 +1272,7 @@
             <a:r>
               <a:rPr lang="en-US" sz="1050">
                 <a:solidFill>
-                  <a:srgbClr val="17201D"/>
+                  <a:srgbClr val="162033"/>
                 </a:solidFill>
               </a:rPr>
               <a:t>对比与消融验证</a:t>
@@ -1204,14 +1282,14 @@
       </p:sp>
       <p:sp>
         <p:nvSpPr>
-          <p:cNvPr id="35" name="Node output_report"/>
-          <p:cNvSpPr/>
-          <p:nvPr/>
-        </p:nvSpPr>
-        <p:spPr>
-          <a:xfrm>
-            <a:off x="10211584" y="3869955"/>
-            <a:ext cx="1189243" cy="387506"/>
+          <p:cNvPr id="36" name="Node output_report"/>
+          <p:cNvSpPr/>
+          <p:nvPr/>
+        </p:nvSpPr>
+        <p:spPr>
+          <a:xfrm>
+            <a:off x="6451440" y="5796933"/>
+            <a:ext cx="1892344" cy="310384"/>
           </a:xfrm>
           <a:prstGeom prst="roundRect">
             <a:avLst/>
@@ -1221,7 +1299,7 @@
           </a:solidFill>
           <a:ln w="12700">
             <a:solidFill>
-              <a:srgbClr val="8BAAA5"/>
+              <a:srgbClr val="9FB6C4"/>
             </a:solidFill>
           </a:ln>
         </p:spPr>
@@ -1233,7 +1311,7 @@
             <a:r>
               <a:rPr lang="en-US" sz="1050">
                 <a:solidFill>
-                  <a:srgbClr val="17201D"/>
+                  <a:srgbClr val="162033"/>
                 </a:solidFill>
               </a:rPr>
               <a:t>输出缺陷报告</a:t>

</xml_diff>

<commit_message>
Refresh research and engineering examples
</commit_message>
<xml_diff>
--- a/examples/academic-paper-demo/outputs/tech-route.pptx
+++ b/examples/academic-paper-demo/outputs/tech-route.pptx
@@ -100,11 +100,11 @@
             <a:avLst/>
           </a:prstGeom>
           <a:solidFill>
-            <a:srgbClr val="E8F3F1"/>
-          </a:solidFill>
-          <a:ln w="12700">
-            <a:solidFill>
-              <a:srgbClr val="E8F3F1"/>
+            <a:srgbClr val="DBEAFE"/>
+          </a:solidFill>
+          <a:ln w="12700">
+            <a:solidFill>
+              <a:srgbClr val="DBEAFE"/>
             </a:solidFill>
           </a:ln>
         </p:spPr>
@@ -116,10 +116,32 @@
             <a:r>
               <a:rPr lang="en-US" sz="2100" b="1">
                 <a:solidFill>
-                  <a:srgbClr val="17201D"/>
-                </a:solidFill>
-              </a:rPr>
-              <a:t>多模态光伏缺陷检测技术路线图</a:t>
+                  <a:srgbClr val="1F2937"/>
+                </a:solidFill>
+              </a:rPr>
+              <a:t>PV Surface Defect</a:t>
+            </a:r>
+          </a:p>
+          <a:p>
+            <a:pPr algn="ctr"/>
+            <a:r>
+              <a:rPr lang="en-US" sz="2100" b="1">
+                <a:solidFill>
+                  <a:srgbClr val="1F2937"/>
+                </a:solidFill>
+              </a:rPr>
+              <a:t>Detection Method</a:t>
+            </a:r>
+          </a:p>
+          <a:p>
+            <a:pPr algn="ctr"/>
+            <a:r>
+              <a:rPr lang="en-US" sz="2100" b="1">
+                <a:solidFill>
+                  <a:srgbClr val="1F2937"/>
+                </a:solidFill>
+              </a:rPr>
+              <a:t>Route</a:t>
             </a:r>
           </a:p>
         </p:txBody>
@@ -155,7 +177,7 @@
             <a:r>
               <a:rPr lang="en-US" sz="850">
                 <a:solidFill>
-                  <a:srgbClr val="59636A"/>
+                  <a:srgbClr val="64748B"/>
                 </a:solidFill>
               </a:rPr>
               <a:t>Academic method</a:t>
@@ -166,7 +188,7 @@
             <a:r>
               <a:rPr lang="en-US" sz="850">
                 <a:solidFill>
-                  <a:srgbClr val="59636A"/>
+                  <a:srgbClr val="64748B"/>
                 </a:solidFill>
               </a:rPr>
               <a:t>framework demo</a:t>
@@ -177,7 +199,7 @@
             <a:r>
               <a:rPr lang="en-US" sz="850">
                 <a:solidFill>
-                  <a:srgbClr val="59636A"/>
+                  <a:srgbClr val="64748B"/>
                 </a:solidFill>
               </a:rPr>
               <a:t>generated by</a:t>
@@ -188,7 +210,7 @@
             <a:r>
               <a:rPr lang="en-US" sz="850">
                 <a:solidFill>
-                  <a:srgbClr val="59636A"/>
+                  <a:srgbClr val="64748B"/>
                 </a:solidFill>
               </a:rPr>
               <a:t>tech-route-maker</a:t>
@@ -198,7 +220,7 @@
       </p:sp>
       <p:sp>
         <p:nvSpPr>
-          <p:cNvPr id="4" name="Stage 研究目标"/>
+          <p:cNvPr id="4" name="Stage Research Goal"/>
           <p:cNvSpPr/>
           <p:nvPr/>
         </p:nvSpPr>
@@ -211,11 +233,11 @@
             <a:avLst/>
           </a:prstGeom>
           <a:solidFill>
-            <a:srgbClr val="E8F3F1"/>
-          </a:solidFill>
-          <a:ln w="12700">
-            <a:solidFill>
-              <a:srgbClr val="B8C7C1"/>
+            <a:srgbClr val="DBEAFE"/>
+          </a:solidFill>
+          <a:ln w="12700">
+            <a:solidFill>
+              <a:srgbClr val="93C5FD"/>
             </a:solidFill>
           </a:ln>
         </p:spPr>
@@ -227,7 +249,7 @@
             <a:r>
               <a:rPr lang="en-US" sz="1000">
                 <a:solidFill>
-                  <a:srgbClr val="17201D"/>
+                  <a:srgbClr val="1F2937"/>
                 </a:solidFill>
               </a:rPr>
               <a:t/>
@@ -237,7 +259,7 @@
       </p:sp>
       <p:sp>
         <p:nvSpPr>
-          <p:cNvPr id="5" name="Label 研究目标"/>
+          <p:cNvPr id="5" name="Label Research Goal"/>
           <p:cNvSpPr/>
           <p:nvPr/>
         </p:nvSpPr>
@@ -250,11 +272,11 @@
             <a:avLst/>
           </a:prstGeom>
           <a:solidFill>
-            <a:srgbClr val="315C61"/>
-          </a:solidFill>
-          <a:ln w="12700">
-            <a:solidFill>
-              <a:srgbClr val="315C61"/>
+            <a:srgbClr val="1D4ED8"/>
+          </a:solidFill>
+          <a:ln w="12700">
+            <a:solidFill>
+              <a:srgbClr val="1D4ED8"/>
             </a:solidFill>
           </a:ln>
         </p:spPr>
@@ -269,14 +291,14 @@
                   <a:srgbClr val="FFFFFF"/>
                 </a:solidFill>
               </a:rPr>
-              <a:t>研究目标</a:t>
-            </a:r>
-          </a:p>
-        </p:txBody>
-      </p:sp>
-      <p:sp>
-        <p:nvSpPr>
-          <p:cNvPr id="6" name="Stage 数据与样本"/>
+              <a:t>Research Goal</a:t>
+            </a:r>
+          </a:p>
+        </p:txBody>
+      </p:sp>
+      <p:sp>
+        <p:nvSpPr>
+          <p:cNvPr id="6" name="Stage Data Evidence"/>
           <p:cNvSpPr/>
           <p:nvPr/>
         </p:nvSpPr>
@@ -289,11 +311,11 @@
             <a:avLst/>
           </a:prstGeom>
           <a:solidFill>
-            <a:srgbClr val="F2EFE6"/>
-          </a:solidFill>
-          <a:ln w="12700">
-            <a:solidFill>
-              <a:srgbClr val="B8C7C1"/>
+            <a:srgbClr val="E0F2FE"/>
+          </a:solidFill>
+          <a:ln w="12700">
+            <a:solidFill>
+              <a:srgbClr val="93C5FD"/>
             </a:solidFill>
           </a:ln>
         </p:spPr>
@@ -305,7 +327,7 @@
             <a:r>
               <a:rPr lang="en-US" sz="1000">
                 <a:solidFill>
-                  <a:srgbClr val="17201D"/>
+                  <a:srgbClr val="1F2937"/>
                 </a:solidFill>
               </a:rPr>
               <a:t/>
@@ -315,7 +337,7 @@
       </p:sp>
       <p:sp>
         <p:nvSpPr>
-          <p:cNvPr id="7" name="Label 数据与样本"/>
+          <p:cNvPr id="7" name="Label Data Evidence"/>
           <p:cNvSpPr/>
           <p:nvPr/>
         </p:nvSpPr>
@@ -328,11 +350,11 @@
             <a:avLst/>
           </a:prstGeom>
           <a:solidFill>
-            <a:srgbClr val="315C61"/>
-          </a:solidFill>
-          <a:ln w="12700">
-            <a:solidFill>
-              <a:srgbClr val="315C61"/>
+            <a:srgbClr val="1D4ED8"/>
+          </a:solidFill>
+          <a:ln w="12700">
+            <a:solidFill>
+              <a:srgbClr val="1D4ED8"/>
             </a:solidFill>
           </a:ln>
         </p:spPr>
@@ -347,14 +369,14 @@
                   <a:srgbClr val="FFFFFF"/>
                 </a:solidFill>
               </a:rPr>
-              <a:t>数据与样本</a:t>
-            </a:r>
-          </a:p>
-        </p:txBody>
-      </p:sp>
-      <p:sp>
-        <p:nvSpPr>
-          <p:cNvPr id="8" name="Stage 方法设计"/>
+              <a:t>Data Evidence</a:t>
+            </a:r>
+          </a:p>
+        </p:txBody>
+      </p:sp>
+      <p:sp>
+        <p:nvSpPr>
+          <p:cNvPr id="8" name="Stage Method Design"/>
           <p:cNvSpPr/>
           <p:nvPr/>
         </p:nvSpPr>
@@ -367,11 +389,11 @@
             <a:avLst/>
           </a:prstGeom>
           <a:solidFill>
-            <a:srgbClr val="EAF0F6"/>
-          </a:solidFill>
-          <a:ln w="12700">
-            <a:solidFill>
-              <a:srgbClr val="B8C7C1"/>
+            <a:srgbClr val="EEF2FF"/>
+          </a:solidFill>
+          <a:ln w="12700">
+            <a:solidFill>
+              <a:srgbClr val="93C5FD"/>
             </a:solidFill>
           </a:ln>
         </p:spPr>
@@ -383,7 +405,7 @@
             <a:r>
               <a:rPr lang="en-US" sz="1000">
                 <a:solidFill>
-                  <a:srgbClr val="17201D"/>
+                  <a:srgbClr val="1F2937"/>
                 </a:solidFill>
               </a:rPr>
               <a:t/>
@@ -393,7 +415,7 @@
       </p:sp>
       <p:sp>
         <p:nvSpPr>
-          <p:cNvPr id="9" name="Label 方法设计"/>
+          <p:cNvPr id="9" name="Label Method Design"/>
           <p:cNvSpPr/>
           <p:nvPr/>
         </p:nvSpPr>
@@ -406,11 +428,11 @@
             <a:avLst/>
           </a:prstGeom>
           <a:solidFill>
-            <a:srgbClr val="315C61"/>
-          </a:solidFill>
-          <a:ln w="12700">
-            <a:solidFill>
-              <a:srgbClr val="315C61"/>
+            <a:srgbClr val="1D4ED8"/>
+          </a:solidFill>
+          <a:ln w="12700">
+            <a:solidFill>
+              <a:srgbClr val="1D4ED8"/>
             </a:solidFill>
           </a:ln>
         </p:spPr>
@@ -425,14 +447,14 @@
                   <a:srgbClr val="FFFFFF"/>
                 </a:solidFill>
               </a:rPr>
-              <a:t>方法设计</a:t>
-            </a:r>
-          </a:p>
-        </p:txBody>
-      </p:sp>
-      <p:sp>
-        <p:nvSpPr>
-          <p:cNvPr id="10" name="Stage 训练优化"/>
+              <a:t>Method Design</a:t>
+            </a:r>
+          </a:p>
+        </p:txBody>
+      </p:sp>
+      <p:sp>
+        <p:nvSpPr>
+          <p:cNvPr id="10" name="Stage Training Validation"/>
           <p:cNvSpPr/>
           <p:nvPr/>
         </p:nvSpPr>
@@ -445,11 +467,11 @@
             <a:avLst/>
           </a:prstGeom>
           <a:solidFill>
-            <a:srgbClr val="F6F1E8"/>
-          </a:solidFill>
-          <a:ln w="12700">
-            <a:solidFill>
-              <a:srgbClr val="B8C7C1"/>
+            <a:srgbClr val="ECFDF5"/>
+          </a:solidFill>
+          <a:ln w="12700">
+            <a:solidFill>
+              <a:srgbClr val="93C5FD"/>
             </a:solidFill>
           </a:ln>
         </p:spPr>
@@ -461,7 +483,7 @@
             <a:r>
               <a:rPr lang="en-US" sz="1000">
                 <a:solidFill>
-                  <a:srgbClr val="17201D"/>
+                  <a:srgbClr val="1F2937"/>
                 </a:solidFill>
               </a:rPr>
               <a:t/>
@@ -471,7 +493,7 @@
       </p:sp>
       <p:sp>
         <p:nvSpPr>
-          <p:cNvPr id="11" name="Label 训练优化"/>
+          <p:cNvPr id="11" name="Label Training Validation"/>
           <p:cNvSpPr/>
           <p:nvPr/>
         </p:nvSpPr>
@@ -484,11 +506,11 @@
             <a:avLst/>
           </a:prstGeom>
           <a:solidFill>
-            <a:srgbClr val="315C61"/>
-          </a:solidFill>
-          <a:ln w="12700">
-            <a:solidFill>
-              <a:srgbClr val="315C61"/>
+            <a:srgbClr val="1D4ED8"/>
+          </a:solidFill>
+          <a:ln w="12700">
+            <a:solidFill>
+              <a:srgbClr val="1D4ED8"/>
             </a:solidFill>
           </a:ln>
         </p:spPr>
@@ -503,14 +525,25 @@
                   <a:srgbClr val="FFFFFF"/>
                 </a:solidFill>
               </a:rPr>
-              <a:t>训练优化</a:t>
-            </a:r>
-          </a:p>
-        </p:txBody>
-      </p:sp>
-      <p:sp>
-        <p:nvSpPr>
-          <p:cNvPr id="12" name="Stage 验证输出"/>
+              <a:t>Training</a:t>
+            </a:r>
+          </a:p>
+          <a:p>
+            <a:pPr algn="ctr"/>
+            <a:r>
+              <a:rPr lang="en-US" sz="1050" b="1">
+                <a:solidFill>
+                  <a:srgbClr val="FFFFFF"/>
+                </a:solidFill>
+              </a:rPr>
+              <a:t>Validation</a:t>
+            </a:r>
+          </a:p>
+        </p:txBody>
+      </p:sp>
+      <p:sp>
+        <p:nvSpPr>
+          <p:cNvPr id="12" name="Stage Validation Output"/>
           <p:cNvSpPr/>
           <p:nvPr/>
         </p:nvSpPr>
@@ -523,11 +556,11 @@
             <a:avLst/>
           </a:prstGeom>
           <a:solidFill>
-            <a:srgbClr val="EDF4EA"/>
-          </a:solidFill>
-          <a:ln w="12700">
-            <a:solidFill>
-              <a:srgbClr val="B8C7C1"/>
+            <a:srgbClr val="FFF7ED"/>
+          </a:solidFill>
+          <a:ln w="12700">
+            <a:solidFill>
+              <a:srgbClr val="93C5FD"/>
             </a:solidFill>
           </a:ln>
         </p:spPr>
@@ -539,7 +572,7 @@
             <a:r>
               <a:rPr lang="en-US" sz="1000">
                 <a:solidFill>
-                  <a:srgbClr val="17201D"/>
+                  <a:srgbClr val="1F2937"/>
                 </a:solidFill>
               </a:rPr>
               <a:t/>
@@ -549,7 +582,7 @@
       </p:sp>
       <p:sp>
         <p:nvSpPr>
-          <p:cNvPr id="13" name="Label 验证输出"/>
+          <p:cNvPr id="13" name="Label Validation Output"/>
           <p:cNvSpPr/>
           <p:nvPr/>
         </p:nvSpPr>
@@ -562,11 +595,11 @@
             <a:avLst/>
           </a:prstGeom>
           <a:solidFill>
-            <a:srgbClr val="315C61"/>
-          </a:solidFill>
-          <a:ln w="12700">
-            <a:solidFill>
-              <a:srgbClr val="315C61"/>
+            <a:srgbClr val="1D4ED8"/>
+          </a:solidFill>
+          <a:ln w="12700">
+            <a:solidFill>
+              <a:srgbClr val="1D4ED8"/>
             </a:solidFill>
           </a:ln>
         </p:spPr>
@@ -581,7 +614,7 @@
                   <a:srgbClr val="FFFFFF"/>
                 </a:solidFill>
               </a:rPr>
-              <a:t>验证输出</a:t>
+              <a:t>Validation Output</a:t>
             </a:r>
           </a:p>
         </p:txBody>
@@ -602,7 +635,7 @@
           </a:prstGeom>
           <a:ln w="19050">
             <a:solidFill>
-              <a:srgbClr val="315C61"/>
+              <a:srgbClr val="2563EB"/>
             </a:solidFill>
             <a:headEnd type="triangle"/>
           </a:ln>
@@ -624,7 +657,7 @@
           </a:prstGeom>
           <a:ln w="19050">
             <a:solidFill>
-              <a:srgbClr val="315C61"/>
+              <a:srgbClr val="2563EB"/>
             </a:solidFill>
             <a:headEnd type="triangle"/>
           </a:ln>
@@ -646,7 +679,7 @@
           </a:prstGeom>
           <a:ln w="19050">
             <a:solidFill>
-              <a:srgbClr val="315C61"/>
+              <a:srgbClr val="2563EB"/>
             </a:solidFill>
             <a:headEnd type="triangle"/>
           </a:ln>
@@ -668,7 +701,7 @@
           </a:prstGeom>
           <a:ln w="19050">
             <a:solidFill>
-              <a:srgbClr val="315C61"/>
+              <a:srgbClr val="2563EB"/>
             </a:solidFill>
             <a:headEnd type="triangle"/>
           </a:ln>
@@ -690,7 +723,7 @@
           </a:prstGeom>
           <a:ln w="19050">
             <a:solidFill>
-              <a:srgbClr val="315C61"/>
+              <a:srgbClr val="2563EB"/>
             </a:solidFill>
             <a:headEnd type="triangle"/>
           </a:ln>
@@ -712,7 +745,7 @@
           </a:prstGeom>
           <a:ln w="19050">
             <a:solidFill>
-              <a:srgbClr val="315C61"/>
+              <a:srgbClr val="2563EB"/>
             </a:solidFill>
             <a:headEnd type="triangle"/>
           </a:ln>
@@ -734,7 +767,7 @@
           </a:prstGeom>
           <a:ln w="19050">
             <a:solidFill>
-              <a:srgbClr val="315C61"/>
+              <a:srgbClr val="2563EB"/>
             </a:solidFill>
             <a:headEnd type="triangle"/>
           </a:ln>
@@ -756,7 +789,7 @@
           </a:prstGeom>
           <a:ln w="19050">
             <a:solidFill>
-              <a:srgbClr val="315C61"/>
+              <a:srgbClr val="2563EB"/>
             </a:solidFill>
             <a:headEnd type="triangle"/>
           </a:ln>
@@ -778,7 +811,7 @@
           </a:prstGeom>
           <a:ln w="19050">
             <a:solidFill>
-              <a:srgbClr val="315C61"/>
+              <a:srgbClr val="2563EB"/>
             </a:solidFill>
             <a:headEnd type="triangle"/>
           </a:ln>
@@ -800,7 +833,7 @@
           </a:prstGeom>
           <a:ln w="19050">
             <a:solidFill>
-              <a:srgbClr val="315C61"/>
+              <a:srgbClr val="2563EB"/>
             </a:solidFill>
             <a:headEnd type="triangle"/>
           </a:ln>
@@ -822,7 +855,7 @@
           </a:prstGeom>
           <a:ln w="19050">
             <a:solidFill>
-              <a:srgbClr val="315C61"/>
+              <a:srgbClr val="2563EB"/>
             </a:solidFill>
             <a:headEnd type="triangle"/>
           </a:ln>
@@ -844,7 +877,7 @@
           </a:prstGeom>
           <a:ln w="19050">
             <a:solidFill>
-              <a:srgbClr val="315C61"/>
+              <a:srgbClr val="2563EB"/>
             </a:solidFill>
             <a:headEnd type="triangle"/>
           </a:ln>
@@ -866,7 +899,7 @@
           </a:prstGeom>
           <a:ln w="19050">
             <a:solidFill>
-              <a:srgbClr val="315C61"/>
+              <a:srgbClr val="2563EB"/>
             </a:solidFill>
             <a:headEnd type="triangle"/>
           </a:ln>
@@ -874,7 +907,7 @@
       </p:cxnSp>
       <p:sp>
         <p:nvSpPr>
-          <p:cNvPr id="27" name="Node objective_task"/>
+          <p:cNvPr id="27" name="Node goal_task"/>
           <p:cNvSpPr/>
           <p:nvPr/>
         </p:nvSpPr>
@@ -891,29 +924,29 @@
           </a:solidFill>
           <a:ln w="12700">
             <a:solidFill>
-              <a:srgbClr val="8BAAA5"/>
-            </a:solidFill>
-          </a:ln>
-        </p:spPr>
-        <p:txBody>
-          <a:bodyPr wrap="square" anchor="ctr"/>
-          <a:lstStyle/>
-          <a:p>
-            <a:pPr algn="ctr"/>
-            <a:r>
-              <a:rPr lang="en-US" sz="1050">
-                <a:solidFill>
-                  <a:srgbClr val="17201D"/>
-                </a:solidFill>
-              </a:rPr>
-              <a:t>明确缺陷检测任务</a:t>
-            </a:r>
-          </a:p>
-        </p:txBody>
-      </p:sp>
-      <p:sp>
-        <p:nvSpPr>
-          <p:cNvPr id="28" name="Node objective_metrics"/>
+              <a:srgbClr val="60A5FA"/>
+            </a:solidFill>
+          </a:ln>
+        </p:spPr>
+        <p:txBody>
+          <a:bodyPr wrap="square" anchor="ctr"/>
+          <a:lstStyle/>
+          <a:p>
+            <a:pPr algn="ctr"/>
+            <a:r>
+              <a:rPr lang="en-US" sz="1050">
+                <a:solidFill>
+                  <a:srgbClr val="1F2937"/>
+                </a:solidFill>
+              </a:rPr>
+              <a:t>Define defect task</a:t>
+            </a:r>
+          </a:p>
+        </p:txBody>
+      </p:sp>
+      <p:sp>
+        <p:nvSpPr>
+          <p:cNvPr id="28" name="Node goal_metric"/>
           <p:cNvSpPr/>
           <p:nvPr/>
         </p:nvSpPr>
@@ -930,29 +963,40 @@
           </a:solidFill>
           <a:ln w="12700">
             <a:solidFill>
-              <a:srgbClr val="8BAAA5"/>
-            </a:solidFill>
-          </a:ln>
-        </p:spPr>
-        <p:txBody>
-          <a:bodyPr wrap="square" anchor="ctr"/>
-          <a:lstStyle/>
-          <a:p>
-            <a:pPr algn="ctr"/>
-            <a:r>
-              <a:rPr lang="en-US" sz="1050">
-                <a:solidFill>
-                  <a:srgbClr val="17201D"/>
-                </a:solidFill>
-              </a:rPr>
-              <a:t>设定评价指标</a:t>
-            </a:r>
-          </a:p>
-        </p:txBody>
-      </p:sp>
-      <p:sp>
-        <p:nvSpPr>
-          <p:cNvPr id="29" name="Node data_capture"/>
+              <a:srgbClr val="60A5FA"/>
+            </a:solidFill>
+          </a:ln>
+        </p:spPr>
+        <p:txBody>
+          <a:bodyPr wrap="square" anchor="ctr"/>
+          <a:lstStyle/>
+          <a:p>
+            <a:pPr algn="ctr"/>
+            <a:r>
+              <a:rPr lang="en-US" sz="1050">
+                <a:solidFill>
+                  <a:srgbClr val="1F2937"/>
+                </a:solidFill>
+              </a:rPr>
+              <a:t>Set evaluation</a:t>
+            </a:r>
+          </a:p>
+          <a:p>
+            <a:pPr algn="ctr"/>
+            <a:r>
+              <a:rPr lang="en-US" sz="1050">
+                <a:solidFill>
+                  <a:srgbClr val="1F2937"/>
+                </a:solidFill>
+              </a:rPr>
+              <a:t>metrics</a:t>
+            </a:r>
+          </a:p>
+        </p:txBody>
+      </p:sp>
+      <p:sp>
+        <p:nvSpPr>
+          <p:cNvPr id="29" name="Node data_collect"/>
           <p:cNvSpPr/>
           <p:nvPr/>
         </p:nvSpPr>
@@ -969,22 +1013,33 @@
           </a:solidFill>
           <a:ln w="12700">
             <a:solidFill>
-              <a:srgbClr val="8BAAA5"/>
-            </a:solidFill>
-          </a:ln>
-        </p:spPr>
-        <p:txBody>
-          <a:bodyPr wrap="square" anchor="ctr"/>
-          <a:lstStyle/>
-          <a:p>
-            <a:pPr algn="ctr"/>
-            <a:r>
-              <a:rPr lang="en-US" sz="1050">
-                <a:solidFill>
-                  <a:srgbClr val="17201D"/>
-                </a:solidFill>
-              </a:rPr>
-              <a:t>采集多模态图像</a:t>
+              <a:srgbClr val="60A5FA"/>
+            </a:solidFill>
+          </a:ln>
+        </p:spPr>
+        <p:txBody>
+          <a:bodyPr wrap="square" anchor="ctr"/>
+          <a:lstStyle/>
+          <a:p>
+            <a:pPr algn="ctr"/>
+            <a:r>
+              <a:rPr lang="en-US" sz="1050">
+                <a:solidFill>
+                  <a:srgbClr val="1F2937"/>
+                </a:solidFill>
+              </a:rPr>
+              <a:t>Collect RGB and IR</a:t>
+            </a:r>
+          </a:p>
+          <a:p>
+            <a:pPr algn="ctr"/>
+            <a:r>
+              <a:rPr lang="en-US" sz="1050">
+                <a:solidFill>
+                  <a:srgbClr val="1F2937"/>
+                </a:solidFill>
+              </a:rPr>
+              <a:t>images</a:t>
             </a:r>
           </a:p>
         </p:txBody>
@@ -1008,22 +1063,33 @@
           </a:solidFill>
           <a:ln w="12700">
             <a:solidFill>
-              <a:srgbClr val="8BAAA5"/>
-            </a:solidFill>
-          </a:ln>
-        </p:spPr>
-        <p:txBody>
-          <a:bodyPr wrap="square" anchor="ctr"/>
-          <a:lstStyle/>
-          <a:p>
-            <a:pPr algn="ctr"/>
-            <a:r>
-              <a:rPr lang="en-US" sz="1050">
-                <a:solidFill>
-                  <a:srgbClr val="17201D"/>
-                </a:solidFill>
-              </a:rPr>
-              <a:t>配准与标注缺陷</a:t>
+              <a:srgbClr val="60A5FA"/>
+            </a:solidFill>
+          </a:ln>
+        </p:spPr>
+        <p:txBody>
+          <a:bodyPr wrap="square" anchor="ctr"/>
+          <a:lstStyle/>
+          <a:p>
+            <a:pPr algn="ctr"/>
+            <a:r>
+              <a:rPr lang="en-US" sz="1050">
+                <a:solidFill>
+                  <a:srgbClr val="1F2937"/>
+                </a:solidFill>
+              </a:rPr>
+              <a:t>Align and annotate</a:t>
+            </a:r>
+          </a:p>
+          <a:p>
+            <a:pPr algn="ctr"/>
+            <a:r>
+              <a:rPr lang="en-US" sz="1050">
+                <a:solidFill>
+                  <a:srgbClr val="1F2937"/>
+                </a:solidFill>
+              </a:rPr>
+              <a:t>defects</a:t>
             </a:r>
           </a:p>
         </p:txBody>
@@ -1047,22 +1113,33 @@
           </a:solidFill>
           <a:ln w="12700">
             <a:solidFill>
-              <a:srgbClr val="8BAAA5"/>
-            </a:solidFill>
-          </a:ln>
-        </p:spPr>
-        <p:txBody>
-          <a:bodyPr wrap="square" anchor="ctr"/>
-          <a:lstStyle/>
-          <a:p>
-            <a:pPr algn="ctr"/>
-            <a:r>
-              <a:rPr lang="en-US" sz="1050">
-                <a:solidFill>
-                  <a:srgbClr val="17201D"/>
-                </a:solidFill>
-              </a:rPr>
-              <a:t>划分训练样本</a:t>
+              <a:srgbClr val="60A5FA"/>
+            </a:solidFill>
+          </a:ln>
+        </p:spPr>
+        <p:txBody>
+          <a:bodyPr wrap="square" anchor="ctr"/>
+          <a:lstStyle/>
+          <a:p>
+            <a:pPr algn="ctr"/>
+            <a:r>
+              <a:rPr lang="en-US" sz="1050">
+                <a:solidFill>
+                  <a:srgbClr val="1F2937"/>
+                </a:solidFill>
+              </a:rPr>
+              <a:t>Prepare train test</a:t>
+            </a:r>
+          </a:p>
+          <a:p>
+            <a:pPr algn="ctr"/>
+            <a:r>
+              <a:rPr lang="en-US" sz="1050">
+                <a:solidFill>
+                  <a:srgbClr val="1F2937"/>
+                </a:solidFill>
+              </a:rPr>
+              <a:t>sets</a:t>
             </a:r>
           </a:p>
         </p:txBody>
@@ -1086,22 +1163,33 @@
           </a:solidFill>
           <a:ln w="12700">
             <a:solidFill>
-              <a:srgbClr val="8BAAA5"/>
-            </a:solidFill>
-          </a:ln>
-        </p:spPr>
-        <p:txBody>
-          <a:bodyPr wrap="square" anchor="ctr"/>
-          <a:lstStyle/>
-          <a:p>
-            <a:pPr algn="ctr"/>
-            <a:r>
-              <a:rPr lang="en-US" sz="1050">
-                <a:solidFill>
-                  <a:srgbClr val="17201D"/>
-                </a:solidFill>
-              </a:rPr>
-              <a:t>建立基线检测器</a:t>
+              <a:srgbClr val="60A5FA"/>
+            </a:solidFill>
+          </a:ln>
+        </p:spPr>
+        <p:txBody>
+          <a:bodyPr wrap="square" anchor="ctr"/>
+          <a:lstStyle/>
+          <a:p>
+            <a:pPr algn="ctr"/>
+            <a:r>
+              <a:rPr lang="en-US" sz="1050">
+                <a:solidFill>
+                  <a:srgbClr val="1F2937"/>
+                </a:solidFill>
+              </a:rPr>
+              <a:t>Build baseline</a:t>
+            </a:r>
+          </a:p>
+          <a:p>
+            <a:pPr algn="ctr"/>
+            <a:r>
+              <a:rPr lang="en-US" sz="1050">
+                <a:solidFill>
+                  <a:srgbClr val="1F2937"/>
+                </a:solidFill>
+              </a:rPr>
+              <a:t>detector</a:t>
             </a:r>
           </a:p>
         </p:txBody>
@@ -1125,22 +1213,33 @@
           </a:solidFill>
           <a:ln w="12700">
             <a:solidFill>
-              <a:srgbClr val="8BAAA5"/>
-            </a:solidFill>
-          </a:ln>
-        </p:spPr>
-        <p:txBody>
-          <a:bodyPr wrap="square" anchor="ctr"/>
-          <a:lstStyle/>
-          <a:p>
-            <a:pPr algn="ctr"/>
-            <a:r>
-              <a:rPr lang="en-US" sz="1050">
-                <a:solidFill>
-                  <a:srgbClr val="17201D"/>
-                </a:solidFill>
-              </a:rPr>
-              <a:t>构建跨模态融合</a:t>
+              <a:srgbClr val="60A5FA"/>
+            </a:solidFill>
+          </a:ln>
+        </p:spPr>
+        <p:txBody>
+          <a:bodyPr wrap="square" anchor="ctr"/>
+          <a:lstStyle/>
+          <a:p>
+            <a:pPr algn="ctr"/>
+            <a:r>
+              <a:rPr lang="en-US" sz="1050">
+                <a:solidFill>
+                  <a:srgbClr val="1F2937"/>
+                </a:solidFill>
+              </a:rPr>
+              <a:t>Fuse multimodal</a:t>
+            </a:r>
+          </a:p>
+          <a:p>
+            <a:pPr algn="ctr"/>
+            <a:r>
+              <a:rPr lang="en-US" sz="1050">
+                <a:solidFill>
+                  <a:srgbClr val="1F2937"/>
+                </a:solidFill>
+              </a:rPr>
+              <a:t>features</a:t>
             </a:r>
           </a:p>
         </p:txBody>
@@ -1164,22 +1263,33 @@
           </a:solidFill>
           <a:ln w="12700">
             <a:solidFill>
-              <a:srgbClr val="8BAAA5"/>
-            </a:solidFill>
-          </a:ln>
-        </p:spPr>
-        <p:txBody>
-          <a:bodyPr wrap="square" anchor="ctr"/>
-          <a:lstStyle/>
-          <a:p>
-            <a:pPr algn="ctr"/>
-            <a:r>
-              <a:rPr lang="en-US" sz="1050">
-                <a:solidFill>
-                  <a:srgbClr val="17201D"/>
-                </a:solidFill>
-              </a:rPr>
-              <a:t>增强关键区域感知</a:t>
+              <a:srgbClr val="60A5FA"/>
+            </a:solidFill>
+          </a:ln>
+        </p:spPr>
+        <p:txBody>
+          <a:bodyPr wrap="square" anchor="ctr"/>
+          <a:lstStyle/>
+          <a:p>
+            <a:pPr algn="ctr"/>
+            <a:r>
+              <a:rPr lang="en-US" sz="1050">
+                <a:solidFill>
+                  <a:srgbClr val="1F2937"/>
+                </a:solidFill>
+              </a:rPr>
+              <a:t>Enhance weak</a:t>
+            </a:r>
+          </a:p>
+          <a:p>
+            <a:pPr algn="ctr"/>
+            <a:r>
+              <a:rPr lang="en-US" sz="1050">
+                <a:solidFill>
+                  <a:srgbClr val="1F2937"/>
+                </a:solidFill>
+              </a:rPr>
+              <a:t>regions</a:t>
             </a:r>
           </a:p>
         </p:txBody>
@@ -1203,22 +1313,33 @@
           </a:solidFill>
           <a:ln w="12700">
             <a:solidFill>
-              <a:srgbClr val="8BAAA5"/>
-            </a:solidFill>
-          </a:ln>
-        </p:spPr>
-        <p:txBody>
-          <a:bodyPr wrap="square" anchor="ctr"/>
-          <a:lstStyle/>
-          <a:p>
-            <a:pPr algn="ctr"/>
-            <a:r>
-              <a:rPr lang="en-US" sz="1050">
-                <a:solidFill>
-                  <a:srgbClr val="17201D"/>
-                </a:solidFill>
-              </a:rPr>
-              <a:t>设计损失函数</a:t>
+              <a:srgbClr val="60A5FA"/>
+            </a:solidFill>
+          </a:ln>
+        </p:spPr>
+        <p:txBody>
+          <a:bodyPr wrap="square" anchor="ctr"/>
+          <a:lstStyle/>
+          <a:p>
+            <a:pPr algn="ctr"/>
+            <a:r>
+              <a:rPr lang="en-US" sz="1050">
+                <a:solidFill>
+                  <a:srgbClr val="1F2937"/>
+                </a:solidFill>
+              </a:rPr>
+              <a:t>Optimize detection</a:t>
+            </a:r>
+          </a:p>
+          <a:p>
+            <a:pPr algn="ctr"/>
+            <a:r>
+              <a:rPr lang="en-US" sz="1050">
+                <a:solidFill>
+                  <a:srgbClr val="1F2937"/>
+                </a:solidFill>
+              </a:rPr>
+              <a:t>losses</a:t>
             </a:r>
           </a:p>
         </p:txBody>
@@ -1242,22 +1363,33 @@
           </a:solidFill>
           <a:ln w="12700">
             <a:solidFill>
-              <a:srgbClr val="8BAAA5"/>
-            </a:solidFill>
-          </a:ln>
-        </p:spPr>
-        <p:txBody>
-          <a:bodyPr wrap="square" anchor="ctr"/>
-          <a:lstStyle/>
-          <a:p>
-            <a:pPr algn="ctr"/>
-            <a:r>
-              <a:rPr lang="en-US" sz="1050">
-                <a:solidFill>
-                  <a:srgbClr val="17201D"/>
-                </a:solidFill>
-              </a:rPr>
-              <a:t>训练与消融实验</a:t>
+              <a:srgbClr val="60A5FA"/>
+            </a:solidFill>
+          </a:ln>
+        </p:spPr>
+        <p:txBody>
+          <a:bodyPr wrap="square" anchor="ctr"/>
+          <a:lstStyle/>
+          <a:p>
+            <a:pPr algn="ctr"/>
+            <a:r>
+              <a:rPr lang="en-US" sz="1050">
+                <a:solidFill>
+                  <a:srgbClr val="1F2937"/>
+                </a:solidFill>
+              </a:rPr>
+              <a:t>Run ablation</a:t>
+            </a:r>
+          </a:p>
+          <a:p>
+            <a:pPr algn="ctr"/>
+            <a:r>
+              <a:rPr lang="en-US" sz="1050">
+                <a:solidFill>
+                  <a:srgbClr val="1F2937"/>
+                </a:solidFill>
+              </a:rPr>
+              <a:t>studies</a:t>
             </a:r>
           </a:p>
         </p:txBody>
@@ -1281,22 +1413,33 @@
           </a:solidFill>
           <a:ln w="12700">
             <a:solidFill>
-              <a:srgbClr val="8BAAA5"/>
-            </a:solidFill>
-          </a:ln>
-        </p:spPr>
-        <p:txBody>
-          <a:bodyPr wrap="square" anchor="ctr"/>
-          <a:lstStyle/>
-          <a:p>
-            <a:pPr algn="ctr"/>
-            <a:r>
-              <a:rPr lang="en-US" sz="1050">
-                <a:solidFill>
-                  <a:srgbClr val="17201D"/>
-                </a:solidFill>
-              </a:rPr>
-              <a:t>推理并筛选结果</a:t>
+              <a:srgbClr val="60A5FA"/>
+            </a:solidFill>
+          </a:ln>
+        </p:spPr>
+        <p:txBody>
+          <a:bodyPr wrap="square" anchor="ctr"/>
+          <a:lstStyle/>
+          <a:p>
+            <a:pPr algn="ctr"/>
+            <a:r>
+              <a:rPr lang="en-US" sz="1050">
+                <a:solidFill>
+                  <a:srgbClr val="1F2937"/>
+                </a:solidFill>
+              </a:rPr>
+              <a:t>Infer defect</a:t>
+            </a:r>
+          </a:p>
+          <a:p>
+            <a:pPr algn="ctr"/>
+            <a:r>
+              <a:rPr lang="en-US" sz="1050">
+                <a:solidFill>
+                  <a:srgbClr val="1F2937"/>
+                </a:solidFill>
+              </a:rPr>
+              <a:t>candidates</a:t>
             </a:r>
           </a:p>
         </p:txBody>
@@ -1320,22 +1463,33 @@
           </a:solidFill>
           <a:ln w="12700">
             <a:solidFill>
-              <a:srgbClr val="8BAAA5"/>
-            </a:solidFill>
-          </a:ln>
-        </p:spPr>
-        <p:txBody>
-          <a:bodyPr wrap="square" anchor="ctr"/>
-          <a:lstStyle/>
-          <a:p>
-            <a:pPr algn="ctr"/>
-            <a:r>
-              <a:rPr lang="en-US" sz="1050">
-                <a:solidFill>
-                  <a:srgbClr val="17201D"/>
-                </a:solidFill>
-              </a:rPr>
-              <a:t>完成指标评估</a:t>
+              <a:srgbClr val="60A5FA"/>
+            </a:solidFill>
+          </a:ln>
+        </p:spPr>
+        <p:txBody>
+          <a:bodyPr wrap="square" anchor="ctr"/>
+          <a:lstStyle/>
+          <a:p>
+            <a:pPr algn="ctr"/>
+            <a:r>
+              <a:rPr lang="en-US" sz="1050">
+                <a:solidFill>
+                  <a:srgbClr val="1F2937"/>
+                </a:solidFill>
+              </a:rPr>
+              <a:t>Report</a:t>
+            </a:r>
+          </a:p>
+          <a:p>
+            <a:pPr algn="ctr"/>
+            <a:r>
+              <a:rPr lang="en-US" sz="1050">
+                <a:solidFill>
+                  <a:srgbClr val="1F2937"/>
+                </a:solidFill>
+              </a:rPr>
+              <a:t>quantitative gains</a:t>
             </a:r>
           </a:p>
         </p:txBody>
@@ -1359,22 +1513,33 @@
           </a:solidFill>
           <a:ln w="12700">
             <a:solidFill>
-              <a:srgbClr val="8BAAA5"/>
-            </a:solidFill>
-          </a:ln>
-        </p:spPr>
-        <p:txBody>
-          <a:bodyPr wrap="square" anchor="ctr"/>
-          <a:lstStyle/>
-          <a:p>
-            <a:pPr algn="ctr"/>
-            <a:r>
-              <a:rPr lang="en-US" sz="1050">
-                <a:solidFill>
-                  <a:srgbClr val="17201D"/>
-                </a:solidFill>
-              </a:rPr>
-              <a:t>生成可视化解释</a:t>
+              <a:srgbClr val="60A5FA"/>
+            </a:solidFill>
+          </a:ln>
+        </p:spPr>
+        <p:txBody>
+          <a:bodyPr wrap="square" anchor="ctr"/>
+          <a:lstStyle/>
+          <a:p>
+            <a:pPr algn="ctr"/>
+            <a:r>
+              <a:rPr lang="en-US" sz="1050">
+                <a:solidFill>
+                  <a:srgbClr val="1F2937"/>
+                </a:solidFill>
+              </a:rPr>
+              <a:t>Explain visual</a:t>
+            </a:r>
+          </a:p>
+          <a:p>
+            <a:pPr algn="ctr"/>
+            <a:r>
+              <a:rPr lang="en-US" sz="1050">
+                <a:solidFill>
+                  <a:srgbClr val="1F2937"/>
+                </a:solidFill>
+              </a:rPr>
+              <a:t>results</a:t>
             </a:r>
           </a:p>
         </p:txBody>
@@ -1398,22 +1563,33 @@
           </a:solidFill>
           <a:ln w="12700">
             <a:solidFill>
-              <a:srgbClr val="8BAAA5"/>
-            </a:solidFill>
-          </a:ln>
-        </p:spPr>
-        <p:txBody>
-          <a:bodyPr wrap="square" anchor="ctr"/>
-          <a:lstStyle/>
-          <a:p>
-            <a:pPr algn="ctr"/>
-            <a:r>
-              <a:rPr lang="en-US" sz="1050">
-                <a:solidFill>
-                  <a:srgbClr val="17201D"/>
-                </a:solidFill>
-              </a:rPr>
-              <a:t>输出缺陷报告</a:t>
+              <a:srgbClr val="60A5FA"/>
+            </a:solidFill>
+          </a:ln>
+        </p:spPr>
+        <p:txBody>
+          <a:bodyPr wrap="square" anchor="ctr"/>
+          <a:lstStyle/>
+          <a:p>
+            <a:pPr algn="ctr"/>
+            <a:r>
+              <a:rPr lang="en-US" sz="1050">
+                <a:solidFill>
+                  <a:srgbClr val="1F2937"/>
+                </a:solidFill>
+              </a:rPr>
+              <a:t>Generate defect</a:t>
+            </a:r>
+          </a:p>
+          <a:p>
+            <a:pPr algn="ctr"/>
+            <a:r>
+              <a:rPr lang="en-US" sz="1050">
+                <a:solidFill>
+                  <a:srgbClr val="1F2937"/>
+                </a:solidFill>
+              </a:rPr>
+              <a:t>report</a:t>
             </a:r>
           </a:p>
         </p:txBody>

</xml_diff>